<commit_message>
fix(ui): stop menu/icons from pushing text out of their boxes; add install section to deliverables
Storefront + admin overflow hardening: category tiles (Shop by Category), the
vehicle-selector widget header/garage row, the site brand, and the admin sidebar
brand/store/nav rows now set min-width:0 and overflow-wrap so icon+label rows
wrap inside their box instead of spilling on long names.

Client deliverables now include the spec's deployment/onboarding path: the report
gains a "Deployment, Installation & Operations" section with the 8-step install
(PARTNERS app, deploy Rails+PG+Redis, scopes, App Proxy subpath, OAuth, metafield
definition, Theme App Extension blocks, import+sync+go-live), and the deck gains a
"Deploy & install on your own store" slide.

Generated with Codebuff 🤖
Co-Authored-By: Codebuff <noreply@codebuff.com>
</commit_message>
<xml_diff>
--- a/report/Vehicle_Selector_Pro_Pitch_Deck.pptx
+++ b/report/Vehicle_Selector_Pro_Pitch_Deck.pptx
@@ -19,6 +19,7 @@
     <p:sldId id="267" r:id="rId18"/>
     <p:sldId id="268" r:id="rId19"/>
     <p:sldId id="269" r:id="rId20"/>
+    <p:sldId id="270" r:id="rId21"/>
   </p:sldIdLst>
   <p:sldSz cx="12191695" cy="6858000" type="screen4x3"/>
   <p:notesSz cx="6858000" cy="9144000"/>
@@ -4715,7 +4716,7 @@
                 </a:solidFill>
                 <a:latin typeface="Calibri"/>
               </a:rPr>
-              <a:t>ROADMAP</a:t>
+              <a:t>GET STARTED</a:t>
             </a:r>
           </a:p>
         </p:txBody>
@@ -4766,7 +4767,7 @@
                 </a:solidFill>
                 <a:latin typeface="Calibri"/>
               </a:rPr>
-              <a:t>A foundation built to grow</a:t>
+              <a:t>Deploy &amp; install on your own store</a:t>
             </a:r>
           </a:p>
         </p:txBody>
@@ -4871,7 +4872,7 @@
                 </a:solidFill>
                 <a:latin typeface="Calibri"/>
               </a:rPr>
-              <a:t>Shopify Billing API for recurring and one-time plans.</a:t>
+              <a:t>Create the app in Shopify Partners — copy the API key &amp; secret, set the app and redirect URLs.</a:t>
             </a:r>
           </a:p>
           <a:p>
@@ -4898,7 +4899,7 @@
                 </a:solidFill>
                 <a:latin typeface="Calibri"/>
               </a:rPr>
-              <a:t>Supersession &amp; OE-number matching for a richer part engine.</a:t>
+              <a:t>Deploy the Rails app to Fly.io / Render with PostgreSQL, Redis and Sidekiq; boot with rails db:prepare.</a:t>
             </a:r>
           </a:p>
           <a:p>
@@ -4925,7 +4926,7 @@
                 </a:solidFill>
                 <a:latin typeface="Calibri"/>
               </a:rPr>
-              <a:t>Fitment confidence scoring and smarter universal/exact priority.</a:t>
+              <a:t>Register the App Proxy subpath /apps/vehicle-selector, then install on the store via OAuth (webhooks auto-register).</a:t>
             </a:r>
           </a:p>
           <a:p>
@@ -4952,7 +4953,61 @@
                 </a:solidFill>
                 <a:latin typeface="Calibri"/>
               </a:rPr>
-              <a:t>White-label theming, translations, and merchant analytics.</a:t>
+              <a:t>Create the one-time custom.vehicle_fitment metafield definition in Admin (Product, JSON, Public read).</a:t>
+            </a:r>
+          </a:p>
+          <a:p>
+            <a:pPr>
+              <a:lnSpc>
+                <a:spcPct val="190000"/>
+              </a:lnSpc>
+              <a:spcAft>
+                <a:spcPts val="760"/>
+              </a:spcAft>
+            </a:pPr>
+            <a:r>
+              <a:rPr sz="1500" b="1">
+                <a:solidFill>
+                  <a:srgbClr val="E04B33"/>
+                </a:solidFill>
+              </a:rPr>
+              <a:t>▪  </a:t>
+            </a:r>
+            <a:r>
+              <a:rPr sz="1500">
+                <a:solidFill>
+                  <a:srgbClr val="282A2E"/>
+                </a:solidFill>
+                <a:latin typeface="Calibri"/>
+              </a:rPr>
+              <a:t>Drop in the Theme App Extension blocks (vehicle selector + fitment badge) and publish the theme.</a:t>
+            </a:r>
+          </a:p>
+          <a:p>
+            <a:pPr>
+              <a:lnSpc>
+                <a:spcPct val="190000"/>
+              </a:lnSpc>
+              <a:spcAft>
+                <a:spcPts val="760"/>
+              </a:spcAft>
+            </a:pPr>
+            <a:r>
+              <a:rPr sz="1500" b="1">
+                <a:solidFill>
+                  <a:srgbClr val="E04B33"/>
+                </a:solidFill>
+              </a:rPr>
+              <a:t>▪  </a:t>
+            </a:r>
+            <a:r>
+              <a:rPr sz="1500">
+                <a:solidFill>
+                  <a:srgbClr val="282A2E"/>
+                </a:solidFill>
+                <a:latin typeface="Calibri"/>
+              </a:rPr>
+              <a:t>Bulk-import fitments, run the sync, verify PDP badges &amp; filters, and go live.</a:t>
             </a:r>
           </a:p>
         </p:txBody>
@@ -5076,7 +5131,7 @@
                 </a:solidFill>
                 <a:latin typeface="Calibri"/>
               </a:rPr>
-              <a:t>BUILD · PROVENANCE</a:t>
+              <a:t>ROADMAP</a:t>
             </a:r>
           </a:p>
         </p:txBody>
@@ -5127,7 +5182,7 @@
                 </a:solidFill>
                 <a:latin typeface="Calibri"/>
               </a:rPr>
-              <a:t>Built entirely with free AI tools</a:t>
+              <a:t>A foundation built to grow</a:t>
             </a:r>
           </a:p>
         </p:txBody>
@@ -5189,6 +5244,367 @@
       </p:sp>
       <p:sp>
         <p:nvSpPr>
+          <p:cNvPr id="6" name="TextBox 5"/>
+          <p:cNvSpPr txBox="1"/>
+          <p:nvPr/>
+        </p:nvSpPr>
+        <p:spPr>
+          <a:xfrm>
+            <a:off x="914400" y="2103120"/>
+            <a:ext cx="10241280" cy="4023360"/>
+          </a:xfrm>
+          <a:prstGeom prst="rect">
+            <a:avLst/>
+          </a:prstGeom>
+          <a:noFill/>
+        </p:spPr>
+        <p:txBody>
+          <a:bodyPr wrap="square">
+            <a:spAutoFit/>
+          </a:bodyPr>
+          <a:lstStyle/>
+          <a:p>
+            <a:pPr>
+              <a:lnSpc>
+                <a:spcPct val="190000"/>
+              </a:lnSpc>
+              <a:spcAft>
+                <a:spcPts val="760"/>
+              </a:spcAft>
+            </a:pPr>
+            <a:r>
+              <a:rPr sz="1500" b="1">
+                <a:solidFill>
+                  <a:srgbClr val="E04B33"/>
+                </a:solidFill>
+              </a:rPr>
+              <a:t>▪  </a:t>
+            </a:r>
+            <a:r>
+              <a:rPr sz="1500">
+                <a:solidFill>
+                  <a:srgbClr val="282A2E"/>
+                </a:solidFill>
+                <a:latin typeface="Calibri"/>
+              </a:rPr>
+              <a:t>Shopify Billing API for recurring and one-time plans.</a:t>
+            </a:r>
+          </a:p>
+          <a:p>
+            <a:pPr>
+              <a:lnSpc>
+                <a:spcPct val="190000"/>
+              </a:lnSpc>
+              <a:spcAft>
+                <a:spcPts val="760"/>
+              </a:spcAft>
+            </a:pPr>
+            <a:r>
+              <a:rPr sz="1500" b="1">
+                <a:solidFill>
+                  <a:srgbClr val="E04B33"/>
+                </a:solidFill>
+              </a:rPr>
+              <a:t>▪  </a:t>
+            </a:r>
+            <a:r>
+              <a:rPr sz="1500">
+                <a:solidFill>
+                  <a:srgbClr val="282A2E"/>
+                </a:solidFill>
+                <a:latin typeface="Calibri"/>
+              </a:rPr>
+              <a:t>Supersession &amp; OE-number matching for a richer part engine.</a:t>
+            </a:r>
+          </a:p>
+          <a:p>
+            <a:pPr>
+              <a:lnSpc>
+                <a:spcPct val="190000"/>
+              </a:lnSpc>
+              <a:spcAft>
+                <a:spcPts val="760"/>
+              </a:spcAft>
+            </a:pPr>
+            <a:r>
+              <a:rPr sz="1500" b="1">
+                <a:solidFill>
+                  <a:srgbClr val="E04B33"/>
+                </a:solidFill>
+              </a:rPr>
+              <a:t>▪  </a:t>
+            </a:r>
+            <a:r>
+              <a:rPr sz="1500">
+                <a:solidFill>
+                  <a:srgbClr val="282A2E"/>
+                </a:solidFill>
+                <a:latin typeface="Calibri"/>
+              </a:rPr>
+              <a:t>Fitment confidence scoring and smarter universal/exact priority.</a:t>
+            </a:r>
+          </a:p>
+          <a:p>
+            <a:pPr>
+              <a:lnSpc>
+                <a:spcPct val="190000"/>
+              </a:lnSpc>
+              <a:spcAft>
+                <a:spcPts val="760"/>
+              </a:spcAft>
+            </a:pPr>
+            <a:r>
+              <a:rPr sz="1500" b="1">
+                <a:solidFill>
+                  <a:srgbClr val="E04B33"/>
+                </a:solidFill>
+              </a:rPr>
+              <a:t>▪  </a:t>
+            </a:r>
+            <a:r>
+              <a:rPr sz="1500">
+                <a:solidFill>
+                  <a:srgbClr val="282A2E"/>
+                </a:solidFill>
+                <a:latin typeface="Calibri"/>
+              </a:rPr>
+              <a:t>White-label theming, translations, and merchant analytics.</a:t>
+            </a:r>
+          </a:p>
+        </p:txBody>
+      </p:sp>
+    </p:spTree>
+  </p:cSld>
+  <p:clrMapOvr>
+    <a:masterClrMapping/>
+  </p:clrMapOvr>
+</p:sld>
+</file>
+
+<file path=ppt/slides/slide14.xml><?xml version="1.0" encoding="utf-8"?>
+<p:sld xmlns:a="http://schemas.openxmlformats.org/drawingml/2006/main" xmlns:p="http://schemas.openxmlformats.org/presentationml/2006/main" xmlns:r="http://schemas.openxmlformats.org/officeDocument/2006/relationships">
+  <p:cSld>
+    <p:spTree>
+      <p:nvGrpSpPr>
+        <p:cNvPr id="1" name=""/>
+        <p:cNvGrpSpPr/>
+        <p:nvPr/>
+      </p:nvGrpSpPr>
+      <p:grpSpPr/>
+      <p:sp>
+        <p:nvSpPr>
+          <p:cNvPr id="2" name="Rectangle 1"/>
+          <p:cNvSpPr/>
+          <p:nvPr/>
+        </p:nvSpPr>
+        <p:spPr>
+          <a:xfrm>
+            <a:off x="0" y="0"/>
+            <a:ext cx="12191695" cy="128016"/>
+          </a:xfrm>
+          <a:prstGeom prst="rect">
+            <a:avLst/>
+          </a:prstGeom>
+          <a:solidFill>
+            <a:srgbClr val="E04B33"/>
+          </a:solidFill>
+          <a:ln>
+            <a:solidFill>
+              <a:srgbClr val="E04B33"/>
+            </a:solidFill>
+          </a:ln>
+          <a:effectLst/>
+        </p:spPr>
+        <p:style>
+          <a:lnRef idx="1">
+            <a:schemeClr val="accent1"/>
+          </a:lnRef>
+          <a:fillRef idx="3">
+            <a:schemeClr val="accent1"/>
+          </a:fillRef>
+          <a:effectRef idx="2">
+            <a:schemeClr val="accent1"/>
+          </a:effectRef>
+          <a:fontRef idx="minor">
+            <a:schemeClr val="lt1"/>
+          </a:fontRef>
+        </p:style>
+        <p:txBody>
+          <a:bodyPr rtlCol="0" anchor="t" wrap="square"/>
+          <a:lstStyle/>
+          <a:p>
+            <a:pPr algn="l"/>
+            <a:r>
+              <a:rPr sz="1400" b="0">
+                <a:solidFill>
+                  <a:srgbClr val="282A2E"/>
+                </a:solidFill>
+                <a:latin typeface="Calibri"/>
+              </a:rPr>
+              <a:t/>
+            </a:r>
+          </a:p>
+        </p:txBody>
+      </p:sp>
+      <p:sp>
+        <p:nvSpPr>
+          <p:cNvPr id="3" name="Rectangle 2"/>
+          <p:cNvSpPr/>
+          <p:nvPr/>
+        </p:nvSpPr>
+        <p:spPr>
+          <a:xfrm>
+            <a:off x="822960" y="548640"/>
+            <a:ext cx="5486400" cy="365760"/>
+          </a:xfrm>
+          <a:prstGeom prst="rect">
+            <a:avLst/>
+          </a:prstGeom>
+          <a:noFill/>
+          <a:ln>
+            <a:noFill/>
+          </a:ln>
+          <a:effectLst/>
+        </p:spPr>
+        <p:style>
+          <a:lnRef idx="1">
+            <a:schemeClr val="accent1"/>
+          </a:lnRef>
+          <a:fillRef idx="3">
+            <a:schemeClr val="accent1"/>
+          </a:fillRef>
+          <a:effectRef idx="2">
+            <a:schemeClr val="accent1"/>
+          </a:effectRef>
+          <a:fontRef idx="minor">
+            <a:schemeClr val="lt1"/>
+          </a:fontRef>
+        </p:style>
+        <p:txBody>
+          <a:bodyPr rtlCol="0" anchor="t" wrap="square"/>
+          <a:lstStyle/>
+          <a:p>
+            <a:pPr algn="l"/>
+            <a:r>
+              <a:rPr sz="1200" b="1">
+                <a:solidFill>
+                  <a:srgbClr val="E04B33"/>
+                </a:solidFill>
+                <a:latin typeface="Calibri"/>
+              </a:rPr>
+              <a:t>BUILD · PROVENANCE</a:t>
+            </a:r>
+          </a:p>
+        </p:txBody>
+      </p:sp>
+      <p:sp>
+        <p:nvSpPr>
+          <p:cNvPr id="4" name="Rectangle 3"/>
+          <p:cNvSpPr/>
+          <p:nvPr/>
+        </p:nvSpPr>
+        <p:spPr>
+          <a:xfrm>
+            <a:off x="822960" y="914400"/>
+            <a:ext cx="10515600" cy="914400"/>
+          </a:xfrm>
+          <a:prstGeom prst="rect">
+            <a:avLst/>
+          </a:prstGeom>
+          <a:noFill/>
+          <a:ln>
+            <a:noFill/>
+          </a:ln>
+          <a:effectLst/>
+        </p:spPr>
+        <p:style>
+          <a:lnRef idx="1">
+            <a:schemeClr val="accent1"/>
+          </a:lnRef>
+          <a:fillRef idx="3">
+            <a:schemeClr val="accent1"/>
+          </a:fillRef>
+          <a:effectRef idx="2">
+            <a:schemeClr val="accent1"/>
+          </a:effectRef>
+          <a:fontRef idx="minor">
+            <a:schemeClr val="lt1"/>
+          </a:fontRef>
+        </p:style>
+        <p:txBody>
+          <a:bodyPr rtlCol="0" anchor="t" wrap="square"/>
+          <a:lstStyle/>
+          <a:p>
+            <a:pPr algn="l"/>
+            <a:r>
+              <a:rPr sz="2800" b="1">
+                <a:solidFill>
+                  <a:srgbClr val="282A2E"/>
+                </a:solidFill>
+                <a:latin typeface="Calibri"/>
+              </a:rPr>
+              <a:t>Built entirely with free AI tools</a:t>
+            </a:r>
+          </a:p>
+        </p:txBody>
+      </p:sp>
+      <p:sp>
+        <p:nvSpPr>
+          <p:cNvPr id="5" name="Rectangle 4"/>
+          <p:cNvSpPr/>
+          <p:nvPr/>
+        </p:nvSpPr>
+        <p:spPr>
+          <a:xfrm>
+            <a:off x="822960" y="1828800"/>
+            <a:ext cx="10515600" cy="27432"/>
+          </a:xfrm>
+          <a:prstGeom prst="rect">
+            <a:avLst/>
+          </a:prstGeom>
+          <a:solidFill>
+            <a:srgbClr val="E04B33"/>
+          </a:solidFill>
+          <a:ln>
+            <a:solidFill>
+              <a:srgbClr val="E04B33"/>
+            </a:solidFill>
+          </a:ln>
+          <a:effectLst/>
+        </p:spPr>
+        <p:style>
+          <a:lnRef idx="1">
+            <a:schemeClr val="accent1"/>
+          </a:lnRef>
+          <a:fillRef idx="3">
+            <a:schemeClr val="accent1"/>
+          </a:fillRef>
+          <a:effectRef idx="2">
+            <a:schemeClr val="accent1"/>
+          </a:effectRef>
+          <a:fontRef idx="minor">
+            <a:schemeClr val="lt1"/>
+          </a:fontRef>
+        </p:style>
+        <p:txBody>
+          <a:bodyPr rtlCol="0" anchor="t" wrap="square"/>
+          <a:lstStyle/>
+          <a:p>
+            <a:pPr algn="l"/>
+            <a:r>
+              <a:rPr sz="1400" b="0">
+                <a:solidFill>
+                  <a:srgbClr val="282A2E"/>
+                </a:solidFill>
+                <a:latin typeface="Calibri"/>
+              </a:rPr>
+              <a:t/>
+            </a:r>
+          </a:p>
+        </p:txBody>
+      </p:sp>
+      <p:sp>
+        <p:nvSpPr>
           <p:cNvPr id="6" name="Rectangle 5"/>
           <p:cNvSpPr/>
           <p:nvPr/>
@@ -5250,7 +5666,7 @@
 </p:sld>
 </file>
 
-<file path=ppt/slides/slide14.xml><?xml version="1.0" encoding="utf-8"?>
+<file path=ppt/slides/slide15.xml><?xml version="1.0" encoding="utf-8"?>
 <p:sld xmlns:a="http://schemas.openxmlformats.org/drawingml/2006/main" xmlns:p="http://schemas.openxmlformats.org/presentationml/2006/main" xmlns:r="http://schemas.openxmlformats.org/officeDocument/2006/relationships">
   <p:cSld>
     <p:spTree>

</xml_diff>

<commit_message>
docs(deliverables): add minimal-hardware provenance + headroom story
Fold the build provenance into the report and pitch deck: everything
was produced on a single 2018 ASUS ZenBook UX433FA (Intel i7-8565U,
16 GB RAM, integrated UHD 620, no GPU) — no paid tools and no paid
hardware. Reframes the ceiling as tooling, not ambition, so a client
sees the headroom. Updates the README free-AI/hardware callout and
streams both demo videos inline from the live Pages site.

🤖 Generated with Codebuff
Co-Authored-By: Codebuff <noreply@codebuff.com>
</commit_message>
<xml_diff>
--- a/report/Vehicle_Selector_Pro_Pitch_Deck.pptx
+++ b/report/Vehicle_Selector_Pro_Pitch_Deck.pptx
@@ -20,6 +20,7 @@
     <p:sldId id="268" r:id="rId19"/>
     <p:sldId id="269" r:id="rId20"/>
     <p:sldId id="270" r:id="rId21"/>
+    <p:sldId id="271" r:id="rId22"/>
   </p:sldIdLst>
   <p:sldSz cx="12191695" cy="6858000" type="screen4x3"/>
   <p:notesSz cx="6858000" cy="9144000"/>
@@ -5543,7 +5544,7 @@
                 </a:solidFill>
                 <a:latin typeface="Calibri"/>
               </a:rPr>
-              <a:t>Built entirely with free AI tools</a:t>
+              <a:t>Built at the ceiling of a 2018 ultrabook</a:t>
             </a:r>
           </a:p>
         </p:txBody>
@@ -5605,6 +5606,367 @@
       </p:sp>
       <p:sp>
         <p:nvSpPr>
+          <p:cNvPr id="6" name="TextBox 5"/>
+          <p:cNvSpPr txBox="1"/>
+          <p:nvPr/>
+        </p:nvSpPr>
+        <p:spPr>
+          <a:xfrm>
+            <a:off x="914400" y="2103120"/>
+            <a:ext cx="10241280" cy="4023360"/>
+          </a:xfrm>
+          <a:prstGeom prst="rect">
+            <a:avLst/>
+          </a:prstGeom>
+          <a:noFill/>
+        </p:spPr>
+        <p:txBody>
+          <a:bodyPr wrap="square">
+            <a:spAutoFit/>
+          </a:bodyPr>
+          <a:lstStyle/>
+          <a:p>
+            <a:pPr>
+              <a:lnSpc>
+                <a:spcPct val="190000"/>
+              </a:lnSpc>
+              <a:spcAft>
+                <a:spcPts val="760"/>
+              </a:spcAft>
+            </a:pPr>
+            <a:r>
+              <a:rPr sz="1500" b="1">
+                <a:solidFill>
+                  <a:srgbClr val="E04B33"/>
+                </a:solidFill>
+              </a:rPr>
+              <a:t>▪  </a:t>
+            </a:r>
+            <a:r>
+              <a:rPr sz="1500">
+                <a:solidFill>
+                  <a:srgbClr val="282A2E"/>
+                </a:solidFill>
+                <a:latin typeface="Calibri"/>
+              </a:rPr>
+              <a:t>The entire project — Rails app, Shopify integration, storefront, diagrams, this deck, and both demo videos — was produced on one machine.</a:t>
+            </a:r>
+          </a:p>
+          <a:p>
+            <a:pPr>
+              <a:lnSpc>
+                <a:spcPct val="190000"/>
+              </a:lnSpc>
+              <a:spcAft>
+                <a:spcPts val="760"/>
+              </a:spcAft>
+            </a:pPr>
+            <a:r>
+              <a:rPr sz="1500" b="1">
+                <a:solidFill>
+                  <a:srgbClr val="E04B33"/>
+                </a:solidFill>
+              </a:rPr>
+              <a:t>▪  </a:t>
+            </a:r>
+            <a:r>
+              <a:rPr sz="1500">
+                <a:solidFill>
+                  <a:srgbClr val="282A2E"/>
+                </a:solidFill>
+                <a:latin typeface="Calibri"/>
+              </a:rPr>
+              <a:t>ASUS ZenBook UX433FA · Intel Core i7-8565U @ 1.80 GHz · 16 GB RAM.</a:t>
+            </a:r>
+          </a:p>
+          <a:p>
+            <a:pPr>
+              <a:lnSpc>
+                <a:spcPct val="190000"/>
+              </a:lnSpc>
+              <a:spcAft>
+                <a:spcPts val="760"/>
+              </a:spcAft>
+            </a:pPr>
+            <a:r>
+              <a:rPr sz="1500" b="1">
+                <a:solidFill>
+                  <a:srgbClr val="E04B33"/>
+                </a:solidFill>
+              </a:rPr>
+              <a:t>▪  </a:t>
+            </a:r>
+            <a:r>
+              <a:rPr sz="1500">
+                <a:solidFill>
+                  <a:srgbClr val="282A2E"/>
+                </a:solidFill>
+                <a:latin typeface="Calibri"/>
+              </a:rPr>
+              <a:t>Intel UHD 620 integrated graphics only — no GPU, no cluster; every frame of both demo videos was rendered on the CPU.</a:t>
+            </a:r>
+          </a:p>
+          <a:p>
+            <a:pPr>
+              <a:lnSpc>
+                <a:spcPct val="190000"/>
+              </a:lnSpc>
+              <a:spcAft>
+                <a:spcPts val="760"/>
+              </a:spcAft>
+            </a:pPr>
+            <a:r>
+              <a:rPr sz="1500" b="1">
+                <a:solidFill>
+                  <a:srgbClr val="E04B33"/>
+                </a:solidFill>
+              </a:rPr>
+              <a:t>▪  </a:t>
+            </a:r>
+            <a:r>
+              <a:rPr sz="1500">
+                <a:solidFill>
+                  <a:srgbClr val="282A2E"/>
+                </a:solidFill>
+                <a:latin typeface="Calibri"/>
+              </a:rPr>
+              <a:t>The output was capped by tooling, not ambition. Given a real workstation, a GPU, and paid frontier models, the same foundation leaps a level.</a:t>
+            </a:r>
+          </a:p>
+        </p:txBody>
+      </p:sp>
+    </p:spTree>
+  </p:cSld>
+  <p:clrMapOvr>
+    <a:masterClrMapping/>
+  </p:clrMapOvr>
+</p:sld>
+</file>
+
+<file path=ppt/slides/slide15.xml><?xml version="1.0" encoding="utf-8"?>
+<p:sld xmlns:a="http://schemas.openxmlformats.org/drawingml/2006/main" xmlns:p="http://schemas.openxmlformats.org/presentationml/2006/main" xmlns:r="http://schemas.openxmlformats.org/officeDocument/2006/relationships">
+  <p:cSld>
+    <p:spTree>
+      <p:nvGrpSpPr>
+        <p:cNvPr id="1" name=""/>
+        <p:cNvGrpSpPr/>
+        <p:nvPr/>
+      </p:nvGrpSpPr>
+      <p:grpSpPr/>
+      <p:sp>
+        <p:nvSpPr>
+          <p:cNvPr id="2" name="Rectangle 1"/>
+          <p:cNvSpPr/>
+          <p:nvPr/>
+        </p:nvSpPr>
+        <p:spPr>
+          <a:xfrm>
+            <a:off x="0" y="0"/>
+            <a:ext cx="12191695" cy="128016"/>
+          </a:xfrm>
+          <a:prstGeom prst="rect">
+            <a:avLst/>
+          </a:prstGeom>
+          <a:solidFill>
+            <a:srgbClr val="E04B33"/>
+          </a:solidFill>
+          <a:ln>
+            <a:solidFill>
+              <a:srgbClr val="E04B33"/>
+            </a:solidFill>
+          </a:ln>
+          <a:effectLst/>
+        </p:spPr>
+        <p:style>
+          <a:lnRef idx="1">
+            <a:schemeClr val="accent1"/>
+          </a:lnRef>
+          <a:fillRef idx="3">
+            <a:schemeClr val="accent1"/>
+          </a:fillRef>
+          <a:effectRef idx="2">
+            <a:schemeClr val="accent1"/>
+          </a:effectRef>
+          <a:fontRef idx="minor">
+            <a:schemeClr val="lt1"/>
+          </a:fontRef>
+        </p:style>
+        <p:txBody>
+          <a:bodyPr rtlCol="0" anchor="t" wrap="square"/>
+          <a:lstStyle/>
+          <a:p>
+            <a:pPr algn="l"/>
+            <a:r>
+              <a:rPr sz="1400" b="0">
+                <a:solidFill>
+                  <a:srgbClr val="282A2E"/>
+                </a:solidFill>
+                <a:latin typeface="Calibri"/>
+              </a:rPr>
+              <a:t/>
+            </a:r>
+          </a:p>
+        </p:txBody>
+      </p:sp>
+      <p:sp>
+        <p:nvSpPr>
+          <p:cNvPr id="3" name="Rectangle 2"/>
+          <p:cNvSpPr/>
+          <p:nvPr/>
+        </p:nvSpPr>
+        <p:spPr>
+          <a:xfrm>
+            <a:off x="822960" y="548640"/>
+            <a:ext cx="5486400" cy="365760"/>
+          </a:xfrm>
+          <a:prstGeom prst="rect">
+            <a:avLst/>
+          </a:prstGeom>
+          <a:noFill/>
+          <a:ln>
+            <a:noFill/>
+          </a:ln>
+          <a:effectLst/>
+        </p:spPr>
+        <p:style>
+          <a:lnRef idx="1">
+            <a:schemeClr val="accent1"/>
+          </a:lnRef>
+          <a:fillRef idx="3">
+            <a:schemeClr val="accent1"/>
+          </a:fillRef>
+          <a:effectRef idx="2">
+            <a:schemeClr val="accent1"/>
+          </a:effectRef>
+          <a:fontRef idx="minor">
+            <a:schemeClr val="lt1"/>
+          </a:fontRef>
+        </p:style>
+        <p:txBody>
+          <a:bodyPr rtlCol="0" anchor="t" wrap="square"/>
+          <a:lstStyle/>
+          <a:p>
+            <a:pPr algn="l"/>
+            <a:r>
+              <a:rPr sz="1200" b="1">
+                <a:solidFill>
+                  <a:srgbClr val="E04B33"/>
+                </a:solidFill>
+                <a:latin typeface="Calibri"/>
+              </a:rPr>
+              <a:t>BUILD · PROVENANCE</a:t>
+            </a:r>
+          </a:p>
+        </p:txBody>
+      </p:sp>
+      <p:sp>
+        <p:nvSpPr>
+          <p:cNvPr id="4" name="Rectangle 3"/>
+          <p:cNvSpPr/>
+          <p:nvPr/>
+        </p:nvSpPr>
+        <p:spPr>
+          <a:xfrm>
+            <a:off x="822960" y="914400"/>
+            <a:ext cx="10515600" cy="914400"/>
+          </a:xfrm>
+          <a:prstGeom prst="rect">
+            <a:avLst/>
+          </a:prstGeom>
+          <a:noFill/>
+          <a:ln>
+            <a:noFill/>
+          </a:ln>
+          <a:effectLst/>
+        </p:spPr>
+        <p:style>
+          <a:lnRef idx="1">
+            <a:schemeClr val="accent1"/>
+          </a:lnRef>
+          <a:fillRef idx="3">
+            <a:schemeClr val="accent1"/>
+          </a:fillRef>
+          <a:effectRef idx="2">
+            <a:schemeClr val="accent1"/>
+          </a:effectRef>
+          <a:fontRef idx="minor">
+            <a:schemeClr val="lt1"/>
+          </a:fontRef>
+        </p:style>
+        <p:txBody>
+          <a:bodyPr rtlCol="0" anchor="t" wrap="square"/>
+          <a:lstStyle/>
+          <a:p>
+            <a:pPr algn="l"/>
+            <a:r>
+              <a:rPr sz="2800" b="1">
+                <a:solidFill>
+                  <a:srgbClr val="282A2E"/>
+                </a:solidFill>
+                <a:latin typeface="Calibri"/>
+              </a:rPr>
+              <a:t>Free tools, minimal hardware — maximum headroom</a:t>
+            </a:r>
+          </a:p>
+        </p:txBody>
+      </p:sp>
+      <p:sp>
+        <p:nvSpPr>
+          <p:cNvPr id="5" name="Rectangle 4"/>
+          <p:cNvSpPr/>
+          <p:nvPr/>
+        </p:nvSpPr>
+        <p:spPr>
+          <a:xfrm>
+            <a:off x="822960" y="1828800"/>
+            <a:ext cx="10515600" cy="27432"/>
+          </a:xfrm>
+          <a:prstGeom prst="rect">
+            <a:avLst/>
+          </a:prstGeom>
+          <a:solidFill>
+            <a:srgbClr val="E04B33"/>
+          </a:solidFill>
+          <a:ln>
+            <a:solidFill>
+              <a:srgbClr val="E04B33"/>
+            </a:solidFill>
+          </a:ln>
+          <a:effectLst/>
+        </p:spPr>
+        <p:style>
+          <a:lnRef idx="1">
+            <a:schemeClr val="accent1"/>
+          </a:lnRef>
+          <a:fillRef idx="3">
+            <a:schemeClr val="accent1"/>
+          </a:fillRef>
+          <a:effectRef idx="2">
+            <a:schemeClr val="accent1"/>
+          </a:effectRef>
+          <a:fontRef idx="minor">
+            <a:schemeClr val="lt1"/>
+          </a:fontRef>
+        </p:style>
+        <p:txBody>
+          <a:bodyPr rtlCol="0" anchor="t" wrap="square"/>
+          <a:lstStyle/>
+          <a:p>
+            <a:pPr algn="l"/>
+            <a:r>
+              <a:rPr sz="1400" b="0">
+                <a:solidFill>
+                  <a:srgbClr val="282A2E"/>
+                </a:solidFill>
+                <a:latin typeface="Calibri"/>
+              </a:rPr>
+              <a:t/>
+            </a:r>
+          </a:p>
+        </p:txBody>
+      </p:sp>
+      <p:sp>
+        <p:nvSpPr>
           <p:cNvPr id="6" name="Rectangle 5"/>
           <p:cNvSpPr/>
           <p:nvPr/>
@@ -5653,7 +6015,7 @@
                 </a:solidFill>
                 <a:latin typeface="Calibri"/>
               </a:rPr>
-              <a:t>Designed, coded, and documented using no paid AI models, APIs, or commercial tooling. That ceiling is deliberate — it proves what free tooling already achieves, and sets up the next stage for a rapid leap forward.</a:t>
+              <a:t>No paid AI models, APIs, or commercial tooling were used anywhere — and the whole result was built and rendered on a 15-watt 2018 ultrabook with no GPU. Both are deliberate. They prove what free tooling on minimal local compute already achieves, and set up a fast leap forward: with proper hardware and paid frontier models, the ceiling lifts dramatically.</a:t>
             </a:r>
           </a:p>
         </p:txBody>
@@ -5666,7 +6028,7 @@
 </p:sld>
 </file>
 
-<file path=ppt/slides/slide15.xml><?xml version="1.0" encoding="utf-8"?>
+<file path=ppt/slides/slide16.xml><?xml version="1.0" encoding="utf-8"?>
 <p:sld xmlns:a="http://schemas.openxmlformats.org/drawingml/2006/main" xmlns:p="http://schemas.openxmlformats.org/presentationml/2006/main" xmlns:r="http://schemas.openxmlformats.org/officeDocument/2006/relationships">
   <p:cSld>
     <p:spTree>

</xml_diff>

<commit_message>
demo(videos): add third live walkthrough and wire it everywhere
New: vehicle-selector-pro-live.mp4 (1:27) recorded against the real
deployed app (vehicle-selector-pro.fly.dev) via a Playwright live tour,
narrated with the same Chatterbox voice. Adds live_record.js +
build_live.py + a live narration script for reproducibility.

Puts all three videos on the README homepage and videos.html, serves the
new file through GitHub Pages, and adds the three walkthrough links as
clickable URLs in the report and pitch deck (regenerated).

🤖 Generated with Codebuff
Co-Authored-By: Codebuff <noreply@codebuff.com>
</commit_message>
<xml_diff>
--- a/report/Vehicle_Selector_Pro_Pitch_Deck.pptx
+++ b/report/Vehicle_Selector_Pro_Pitch_Deck.pptx
@@ -21,6 +21,7 @@
     <p:sldId id="269" r:id="rId20"/>
     <p:sldId id="270" r:id="rId21"/>
     <p:sldId id="271" r:id="rId22"/>
+    <p:sldId id="272" r:id="rId23"/>
   </p:sldIdLst>
   <p:sldSz cx="12191695" cy="6858000" type="screen4x3"/>
   <p:notesSz cx="6858000" cy="9144000"/>
@@ -6029,6 +6030,340 @@
 </file>
 
 <file path=ppt/slides/slide16.xml><?xml version="1.0" encoding="utf-8"?>
+<p:sld xmlns:a="http://schemas.openxmlformats.org/drawingml/2006/main" xmlns:p="http://schemas.openxmlformats.org/presentationml/2006/main" xmlns:r="http://schemas.openxmlformats.org/officeDocument/2006/relationships">
+  <p:cSld>
+    <p:spTree>
+      <p:nvGrpSpPr>
+        <p:cNvPr id="1" name=""/>
+        <p:cNvGrpSpPr/>
+        <p:nvPr/>
+      </p:nvGrpSpPr>
+      <p:grpSpPr/>
+      <p:sp>
+        <p:nvSpPr>
+          <p:cNvPr id="2" name="Rectangle 1"/>
+          <p:cNvSpPr/>
+          <p:nvPr/>
+        </p:nvSpPr>
+        <p:spPr>
+          <a:xfrm>
+            <a:off x="0" y="0"/>
+            <a:ext cx="12191695" cy="128016"/>
+          </a:xfrm>
+          <a:prstGeom prst="rect">
+            <a:avLst/>
+          </a:prstGeom>
+          <a:solidFill>
+            <a:srgbClr val="E04B33"/>
+          </a:solidFill>
+          <a:ln>
+            <a:solidFill>
+              <a:srgbClr val="E04B33"/>
+            </a:solidFill>
+          </a:ln>
+          <a:effectLst/>
+        </p:spPr>
+        <p:style>
+          <a:lnRef idx="1">
+            <a:schemeClr val="accent1"/>
+          </a:lnRef>
+          <a:fillRef idx="3">
+            <a:schemeClr val="accent1"/>
+          </a:fillRef>
+          <a:effectRef idx="2">
+            <a:schemeClr val="accent1"/>
+          </a:effectRef>
+          <a:fontRef idx="minor">
+            <a:schemeClr val="lt1"/>
+          </a:fontRef>
+        </p:style>
+        <p:txBody>
+          <a:bodyPr rtlCol="0" anchor="t" wrap="square"/>
+          <a:lstStyle/>
+          <a:p>
+            <a:pPr algn="l"/>
+            <a:r>
+              <a:rPr sz="1400" b="0">
+                <a:solidFill>
+                  <a:srgbClr val="282A2E"/>
+                </a:solidFill>
+                <a:latin typeface="Calibri"/>
+              </a:rPr>
+              <a:t/>
+            </a:r>
+          </a:p>
+        </p:txBody>
+      </p:sp>
+      <p:sp>
+        <p:nvSpPr>
+          <p:cNvPr id="3" name="Rectangle 2"/>
+          <p:cNvSpPr/>
+          <p:nvPr/>
+        </p:nvSpPr>
+        <p:spPr>
+          <a:xfrm>
+            <a:off x="822960" y="548640"/>
+            <a:ext cx="5486400" cy="365760"/>
+          </a:xfrm>
+          <a:prstGeom prst="rect">
+            <a:avLst/>
+          </a:prstGeom>
+          <a:noFill/>
+          <a:ln>
+            <a:noFill/>
+          </a:ln>
+          <a:effectLst/>
+        </p:spPr>
+        <p:style>
+          <a:lnRef idx="1">
+            <a:schemeClr val="accent1"/>
+          </a:lnRef>
+          <a:fillRef idx="3">
+            <a:schemeClr val="accent1"/>
+          </a:fillRef>
+          <a:effectRef idx="2">
+            <a:schemeClr val="accent1"/>
+          </a:effectRef>
+          <a:fontRef idx="minor">
+            <a:schemeClr val="lt1"/>
+          </a:fontRef>
+        </p:style>
+        <p:txBody>
+          <a:bodyPr rtlCol="0" anchor="t" wrap="square"/>
+          <a:lstStyle/>
+          <a:p>
+            <a:pPr algn="l"/>
+            <a:r>
+              <a:rPr sz="1200" b="1">
+                <a:solidFill>
+                  <a:srgbClr val="E04B33"/>
+                </a:solidFill>
+                <a:latin typeface="Calibri"/>
+              </a:rPr>
+              <a:t>SEE IT LIVE</a:t>
+            </a:r>
+          </a:p>
+        </p:txBody>
+      </p:sp>
+      <p:sp>
+        <p:nvSpPr>
+          <p:cNvPr id="4" name="Rectangle 3"/>
+          <p:cNvSpPr/>
+          <p:nvPr/>
+        </p:nvSpPr>
+        <p:spPr>
+          <a:xfrm>
+            <a:off x="822960" y="914400"/>
+            <a:ext cx="10515600" cy="914400"/>
+          </a:xfrm>
+          <a:prstGeom prst="rect">
+            <a:avLst/>
+          </a:prstGeom>
+          <a:noFill/>
+          <a:ln>
+            <a:noFill/>
+          </a:ln>
+          <a:effectLst/>
+        </p:spPr>
+        <p:style>
+          <a:lnRef idx="1">
+            <a:schemeClr val="accent1"/>
+          </a:lnRef>
+          <a:fillRef idx="3">
+            <a:schemeClr val="accent1"/>
+          </a:fillRef>
+          <a:effectRef idx="2">
+            <a:schemeClr val="accent1"/>
+          </a:effectRef>
+          <a:fontRef idx="minor">
+            <a:schemeClr val="lt1"/>
+          </a:fontRef>
+        </p:style>
+        <p:txBody>
+          <a:bodyPr rtlCol="0" anchor="t" wrap="square"/>
+          <a:lstStyle/>
+          <a:p>
+            <a:pPr algn="l"/>
+            <a:r>
+              <a:rPr sz="2800" b="1">
+                <a:solidFill>
+                  <a:srgbClr val="282A2E"/>
+                </a:solidFill>
+                <a:latin typeface="Calibri"/>
+              </a:rPr>
+              <a:t>Watch the three narrated walkthroughs</a:t>
+            </a:r>
+          </a:p>
+        </p:txBody>
+      </p:sp>
+      <p:sp>
+        <p:nvSpPr>
+          <p:cNvPr id="5" name="Rectangle 4"/>
+          <p:cNvSpPr/>
+          <p:nvPr/>
+        </p:nvSpPr>
+        <p:spPr>
+          <a:xfrm>
+            <a:off x="822960" y="1828800"/>
+            <a:ext cx="10515600" cy="27432"/>
+          </a:xfrm>
+          <a:prstGeom prst="rect">
+            <a:avLst/>
+          </a:prstGeom>
+          <a:solidFill>
+            <a:srgbClr val="E04B33"/>
+          </a:solidFill>
+          <a:ln>
+            <a:solidFill>
+              <a:srgbClr val="E04B33"/>
+            </a:solidFill>
+          </a:ln>
+          <a:effectLst/>
+        </p:spPr>
+        <p:style>
+          <a:lnRef idx="1">
+            <a:schemeClr val="accent1"/>
+          </a:lnRef>
+          <a:fillRef idx="3">
+            <a:schemeClr val="accent1"/>
+          </a:fillRef>
+          <a:effectRef idx="2">
+            <a:schemeClr val="accent1"/>
+          </a:effectRef>
+          <a:fontRef idx="minor">
+            <a:schemeClr val="lt1"/>
+          </a:fontRef>
+        </p:style>
+        <p:txBody>
+          <a:bodyPr rtlCol="0" anchor="t" wrap="square"/>
+          <a:lstStyle/>
+          <a:p>
+            <a:pPr algn="l"/>
+            <a:r>
+              <a:rPr sz="1400" b="0">
+                <a:solidFill>
+                  <a:srgbClr val="282A2E"/>
+                </a:solidFill>
+                <a:latin typeface="Calibri"/>
+              </a:rPr>
+              <a:t/>
+            </a:r>
+          </a:p>
+        </p:txBody>
+      </p:sp>
+      <p:sp>
+        <p:nvSpPr>
+          <p:cNvPr id="6" name="TextBox 5"/>
+          <p:cNvSpPr txBox="1"/>
+          <p:nvPr/>
+        </p:nvSpPr>
+        <p:spPr>
+          <a:xfrm>
+            <a:off x="914400" y="2103120"/>
+            <a:ext cx="10241280" cy="4023360"/>
+          </a:xfrm>
+          <a:prstGeom prst="rect">
+            <a:avLst/>
+          </a:prstGeom>
+          <a:noFill/>
+        </p:spPr>
+        <p:txBody>
+          <a:bodyPr wrap="square">
+            <a:spAutoFit/>
+          </a:bodyPr>
+          <a:lstStyle/>
+          <a:p>
+            <a:pPr>
+              <a:lnSpc>
+                <a:spcPct val="190000"/>
+              </a:lnSpc>
+              <a:spcAft>
+                <a:spcPts val="760"/>
+              </a:spcAft>
+            </a:pPr>
+            <a:r>
+              <a:rPr sz="1500" b="1">
+                <a:solidFill>
+                  <a:srgbClr val="E04B33"/>
+                </a:solidFill>
+              </a:rPr>
+              <a:t>▪  </a:t>
+            </a:r>
+            <a:r>
+              <a:rPr sz="1500">
+                <a:solidFill>
+                  <a:srgbClr val="282A2E"/>
+                </a:solidFill>
+                <a:latin typeface="Calibri"/>
+              </a:rPr>
+              <a:t>Live application — &lt;a href='https://ai-dev-2024.github.io/vehicle-selector-pro/demo/vehicle-selector-pro-live.mp4'&gt;&lt;font color='#E04B33'&gt;&lt;b&gt;watch the real deployment&lt;/b&gt;&lt;/font&gt;&lt;/a&gt; · 1:27</a:t>
+            </a:r>
+          </a:p>
+          <a:p>
+            <a:pPr>
+              <a:lnSpc>
+                <a:spcPct val="190000"/>
+              </a:lnSpc>
+              <a:spcAft>
+                <a:spcPts val="760"/>
+              </a:spcAft>
+            </a:pPr>
+            <a:r>
+              <a:rPr sz="1500" b="1">
+                <a:solidFill>
+                  <a:srgbClr val="E04B33"/>
+                </a:solidFill>
+              </a:rPr>
+              <a:t>▪  </a:t>
+            </a:r>
+            <a:r>
+              <a:rPr sz="1500">
+                <a:solidFill>
+                  <a:srgbClr val="282A2E"/>
+                </a:solidFill>
+                <a:latin typeface="Calibri"/>
+              </a:rPr>
+              <a:t>Merchant command center — &lt;a href='https://ai-dev-2024.github.io/vehicle-selector-pro/demo/vehicle-selector-pro-merchant.mp4'&gt;&lt;font color='#E04B33'&gt;&lt;b&gt;watch&lt;/b&gt;&lt;/font&gt;&lt;/a&gt; · 2:09</a:t>
+            </a:r>
+          </a:p>
+          <a:p>
+            <a:pPr>
+              <a:lnSpc>
+                <a:spcPct val="190000"/>
+              </a:lnSpc>
+              <a:spcAft>
+                <a:spcPts val="760"/>
+              </a:spcAft>
+            </a:pPr>
+            <a:r>
+              <a:rPr sz="1500" b="1">
+                <a:solidFill>
+                  <a:srgbClr val="E04B33"/>
+                </a:solidFill>
+              </a:rPr>
+              <a:t>▪  </a:t>
+            </a:r>
+            <a:r>
+              <a:rPr sz="1500">
+                <a:solidFill>
+                  <a:srgbClr val="282A2E"/>
+                </a:solidFill>
+                <a:latin typeface="Calibri"/>
+              </a:rPr>
+              <a:t>Shopper experience — &lt;a href='https://ai-dev-2024.github.io/vehicle-selector-pro/demo/vehicle-selector-pro-shopper.mp4'&gt;&lt;font color='#E04B33'&gt;&lt;b&gt;watch&lt;/b&gt;&lt;/font&gt;&lt;/a&gt; · 2:21</a:t>
+            </a:r>
+          </a:p>
+        </p:txBody>
+      </p:sp>
+    </p:spTree>
+  </p:cSld>
+  <p:clrMapOvr>
+    <a:masterClrMapping/>
+  </p:clrMapOvr>
+</p:sld>
+</file>
+
+<file path=ppt/slides/slide17.xml><?xml version="1.0" encoding="utf-8"?>
 <p:sld xmlns:a="http://schemas.openxmlformats.org/drawingml/2006/main" xmlns:p="http://schemas.openxmlformats.org/presentationml/2006/main" xmlns:r="http://schemas.openxmlformats.org/officeDocument/2006/relationships">
   <p:cSld>
     <p:spTree>

</xml_diff>

<commit_message>
demo(videos): music, punchier pacing, and true inline homepage playback
Rework the three demo videos: merchant (2:34) and shopper (2:44) get a
lighter, fuller presentation with a music bed ducked under the narrative
and extended to the 2.5-3 min target; the live walkthrough grows to 2:25
with more real pages (vehicles, imports, settings, support). Adds a light
music bed to all three.

All three are uploaded as GitHub user-attachments so they play inline on
the repository homepage (YouTube-style) instead of linking out. Adds
scripts/mix_music.py, and refreshes the report + pitch deck.

🤖 Generated with Codebuff
Co-Authored-By: Codebuff <noreply@codebuff.com>
</commit_message>
<xml_diff>
--- a/report/Vehicle_Selector_Pro_Pitch_Deck.pptx
+++ b/report/Vehicle_Selector_Pro_Pitch_Deck.pptx
@@ -6296,7 +6296,7 @@
                 </a:solidFill>
                 <a:latin typeface="Calibri"/>
               </a:rPr>
-              <a:t>Live application — &lt;a href='https://ai-dev-2024.github.io/vehicle-selector-pro/demo/vehicle-selector-pro-live.mp4'&gt;&lt;font color='#E04B33'&gt;&lt;b&gt;watch the real deployment&lt;/b&gt;&lt;/font&gt;&lt;/a&gt; · 1:27</a:t>
+              <a:t>Live application — &lt;a href='https://ai-dev-2024.github.io/vehicle-selector-pro/demo/vehicle-selector-pro-live.mp4'&gt;&lt;font color='#E04B33'&gt;&lt;b&gt;watch the real deployment&lt;/b&gt;&lt;/font&gt;&lt;/a&gt; · 2:25</a:t>
             </a:r>
           </a:p>
           <a:p>
@@ -6323,7 +6323,7 @@
                 </a:solidFill>
                 <a:latin typeface="Calibri"/>
               </a:rPr>
-              <a:t>Merchant command center — &lt;a href='https://ai-dev-2024.github.io/vehicle-selector-pro/demo/vehicle-selector-pro-merchant.mp4'&gt;&lt;font color='#E04B33'&gt;&lt;b&gt;watch&lt;/b&gt;&lt;/font&gt;&lt;/a&gt; · 2:09</a:t>
+              <a:t>Merchant command center — &lt;a href='https://ai-dev-2024.github.io/vehicle-selector-pro/demo/vehicle-selector-pro-merchant.mp4'&gt;&lt;font color='#E04B33'&gt;&lt;b&gt;watch&lt;/b&gt;&lt;/font&gt;&lt;/a&gt; · 2:34</a:t>
             </a:r>
           </a:p>
           <a:p>
@@ -6350,7 +6350,7 @@
                 </a:solidFill>
                 <a:latin typeface="Calibri"/>
               </a:rPr>
-              <a:t>Shopper experience — &lt;a href='https://ai-dev-2024.github.io/vehicle-selector-pro/demo/vehicle-selector-pro-shopper.mp4'&gt;&lt;font color='#E04B33'&gt;&lt;b&gt;watch&lt;/b&gt;&lt;/font&gt;&lt;/a&gt; · 2:21</a:t>
+              <a:t>Shopper experience — &lt;a href='https://ai-dev-2024.github.io/vehicle-selector-pro/demo/vehicle-selector-pro-shopper.mp4'&gt;&lt;font color='#E04B33'&gt;&lt;b&gt;watch&lt;/b&gt;&lt;/font&gt;&lt;/a&gt; · 2:44</a:t>
             </a:r>
           </a:p>
         </p:txBody>

</xml_diff>

<commit_message>
fix(deliverables): show screenshots full-size/high-res; keep deck at 5 visual slides
The report no longer squeezes all screenshots into one compressed two-column
grid — each capture is now full-width at native 1920x1080 with its caption,
so the catalog section grows to several pages and stays inspectable. The
pitch deck keeps its 5-slide format but shows the two product screenshots at
proper 16:9 aspect ratio (undistorted) on the Problem slide, next to bullets.

Generated with Codebuff 🤖
Co-Authored-By: Codebuff <noreply@codebuff.com>
</commit_message>
<xml_diff>
--- a/report/Vehicle_Selector_Pro_Pitch_Deck.pptx
+++ b/report/Vehicle_Selector_Pro_Pitch_Deck.pptx
@@ -4012,7 +4012,7 @@
       </p:pic>
       <p:pic>
         <p:nvPicPr>
-          <p:cNvPr id="9" name="Picture 8" descr="08_storefront_pdp.png"/>
+          <p:cNvPr id="9" name="Picture 8" descr="01_dashboard.png"/>
           <p:cNvPicPr>
             <a:picLocks noChangeAspect="1"/>
           </p:cNvPicPr>
@@ -4027,54 +4027,6 @@
         <p:spPr>
           <a:xfrm>
             <a:off x="3451860" y="3657600"/>
-            <a:ext cx="2217420" cy="1247298"/>
-          </a:xfrm>
-          <a:prstGeom prst="rect">
-            <a:avLst/>
-          </a:prstGeom>
-        </p:spPr>
-      </p:pic>
-      <p:pic>
-        <p:nvPicPr>
-          <p:cNvPr id="10" name="Picture 9" descr="03_fitment_rules.png"/>
-          <p:cNvPicPr>
-            <a:picLocks noChangeAspect="1"/>
-          </p:cNvPicPr>
-          <p:nvPr/>
-        </p:nvPicPr>
-        <p:blipFill>
-          <a:blip r:embed="rId4"/>
-          <a:stretch>
-            <a:fillRect/>
-          </a:stretch>
-        </p:blipFill>
-        <p:spPr>
-          <a:xfrm>
-            <a:off x="914400" y="5120640"/>
-            <a:ext cx="2217420" cy="1247298"/>
-          </a:xfrm>
-          <a:prstGeom prst="rect">
-            <a:avLst/>
-          </a:prstGeom>
-        </p:spPr>
-      </p:pic>
-      <p:pic>
-        <p:nvPicPr>
-          <p:cNvPr id="11" name="Picture 10" descr="01_dashboard.png"/>
-          <p:cNvPicPr>
-            <a:picLocks noChangeAspect="1"/>
-          </p:cNvPicPr>
-          <p:nvPr/>
-        </p:nvPicPr>
-        <p:blipFill>
-          <a:blip r:embed="rId5"/>
-          <a:stretch>
-            <a:fillRect/>
-          </a:stretch>
-        </p:blipFill>
-        <p:spPr>
-          <a:xfrm>
-            <a:off x="3451860" y="5120640"/>
             <a:ext cx="2217420" cy="1247298"/>
           </a:xfrm>
           <a:prstGeom prst="rect">

</xml_diff>

<commit_message>
docs(deliverables): make every link clickable in report and pitch deck
Wires the deploy-step placeholder URL in the report PDF through a linkify
helper (with XML escaping) and adds real external hyperlinks to the pitch
deck PPTX title and CTA links, so all URLs in both client deliverables open
the target when clicked.

🤖 Generated with Codebuff
Co-Authored-By: Codebuff <noreply@codebuff.com>
</commit_message>
<xml_diff>
--- a/report/Vehicle_Selector_Pro_Pitch_Deck.pptx
+++ b/report/Vehicle_Selector_Pro_Pitch_Deck.pptx
@@ -3539,13 +3539,23 @@
           <a:lstStyle/>
           <a:p>
             <a:r>
-              <a:rPr sz="1300">
-                <a:solidFill>
-                  <a:srgbClr val="E04B33"/>
+              <a:rPr sz="1300" b="1">
+                <a:solidFill>
+                  <a:srgbClr val="282A2E"/>
                 </a:solidFill>
                 <a:latin typeface="Calibri"/>
               </a:rPr>
-              <a:t>Live demo:  https://vehicle-selector-pro.fly.dev/demo</a:t>
+              <a:t>Live demo:  </a:t>
+            </a:r>
+            <a:r>
+              <a:rPr sz="1300" u="sng">
+                <a:solidFill>
+                  <a:srgbClr val="E04B33"/>
+                </a:solidFill>
+                <a:latin typeface="Calibri"/>
+                <a:hlinkClick r:id="rId2"/>
+              </a:rPr>
+              <a:t>https://vehicle-selector-pro.fly.dev/demo</a:t>
             </a:r>
           </a:p>
         </p:txBody>
@@ -3573,13 +3583,23 @@
           <a:lstStyle/>
           <a:p>
             <a:r>
-              <a:rPr sz="1300">
-                <a:solidFill>
-                  <a:srgbClr val="E04B33"/>
+              <a:rPr sz="1300" b="1">
+                <a:solidFill>
+                  <a:srgbClr val="282A2E"/>
                 </a:solidFill>
                 <a:latin typeface="Calibri"/>
               </a:rPr>
-              <a:t>Merchant admin:  https://vehicle-selector-pro.fly.dev/demo/admin</a:t>
+              <a:t>Merchant admin:  </a:t>
+            </a:r>
+            <a:r>
+              <a:rPr sz="1300" u="sng">
+                <a:solidFill>
+                  <a:srgbClr val="E04B33"/>
+                </a:solidFill>
+                <a:latin typeface="Calibri"/>
+                <a:hlinkClick r:id="rId3"/>
+              </a:rPr>
+              <a:t>https://vehicle-selector-pro.fly.dev/demo/admin</a:t>
             </a:r>
           </a:p>
         </p:txBody>
@@ -3607,13 +3627,23 @@
           <a:lstStyle/>
           <a:p>
             <a:r>
-              <a:rPr sz="1300">
-                <a:solidFill>
-                  <a:srgbClr val="E04B33"/>
+              <a:rPr sz="1300" b="1">
+                <a:solidFill>
+                  <a:srgbClr val="282A2E"/>
                 </a:solidFill>
                 <a:latin typeface="Calibri"/>
               </a:rPr>
-              <a:t>Repository:  https://github.com/ai-dev-2024/vehicle-selector-pro</a:t>
+              <a:t>Repository:  </a:t>
+            </a:r>
+            <a:r>
+              <a:rPr sz="1300" u="sng">
+                <a:solidFill>
+                  <a:srgbClr val="E04B33"/>
+                </a:solidFill>
+                <a:latin typeface="Calibri"/>
+                <a:hlinkClick r:id="rId4"/>
+              </a:rPr>
+              <a:t>https://github.com/ai-dev-2024/vehicle-selector-pro</a:t>
             </a:r>
           </a:p>
         </p:txBody>
@@ -5661,6 +5691,7 @@
                   <a:srgbClr val="282A2E"/>
                 </a:solidFill>
                 <a:latin typeface="Calibri"/>
+                <a:hlinkClick r:id="rId2"/>
               </a:rPr>
               <a:t>Try the live storefront demo</a:t>
             </a:r>
@@ -5765,6 +5796,7 @@
                   <a:srgbClr val="282A2E"/>
                 </a:solidFill>
                 <a:latin typeface="Calibri"/>
+                <a:hlinkClick r:id="rId3"/>
               </a:rPr>
               <a:t>Explore the merchant admin</a:t>
             </a:r>
@@ -5869,6 +5901,7 @@
                   <a:srgbClr val="282A2E"/>
                 </a:solidFill>
                 <a:latin typeface="Calibri"/>
+                <a:hlinkClick r:id="rId4"/>
               </a:rPr>
               <a:t>Open the repository</a:t>
             </a:r>
@@ -5973,6 +6006,7 @@
                   <a:srgbClr val="282A2E"/>
                 </a:solidFill>
                 <a:latin typeface="Calibri"/>
+                <a:hlinkClick r:id="rId5"/>
               </a:rPr>
               <a:t>Watch the two narrated walkthroughs</a:t>
             </a:r>

</xml_diff>

<commit_message>
docs(deliverables): publish v2 report + pitch deck to the stable client URLs (402 fitments, 74 products)
</commit_message>
<xml_diff>
--- a/report/Vehicle_Selector_Pro_Pitch_Deck.pptx
+++ b/report/Vehicle_Selector_Pro_Pitch_Deck.pptx
@@ -4014,6 +4014,33 @@
               <a:t>Paid fitment feeds lock merchants into contracts</a:t>
             </a:r>
           </a:p>
+          <a:p>
+            <a:pPr>
+              <a:lnSpc>
+                <a:spcPct val="150000"/>
+              </a:lnSpc>
+              <a:spcAft>
+                <a:spcPts val="600"/>
+              </a:spcAft>
+            </a:pPr>
+            <a:r>
+              <a:rPr sz="1200" b="1">
+                <a:solidFill>
+                  <a:srgbClr val="E04B33"/>
+                </a:solidFill>
+              </a:rPr>
+              <a:t>▪  </a:t>
+            </a:r>
+            <a:r>
+              <a:rPr sz="1200">
+                <a:solidFill>
+                  <a:srgbClr val="282A2E"/>
+                </a:solidFill>
+                <a:latin typeface="Calibri"/>
+              </a:rPr>
+              <a:t>Built end-to-end with free AI tooling on a 2018 ASUS ZenBook — proof of the headroom ahead</a:t>
+            </a:r>
+          </a:p>
         </p:txBody>
       </p:sp>
       <p:pic>
@@ -4450,7 +4477,7 @@
                 </a:solidFill>
                 <a:latin typeface="Calibri"/>
               </a:rPr>
-              <a:t>204</a:t>
+              <a:t>402</a:t>
             </a:r>
           </a:p>
         </p:txBody>
@@ -4556,7 +4583,7 @@
                 </a:solidFill>
                 <a:latin typeface="Calibri"/>
               </a:rPr>
-              <a:t>40</a:t>
+              <a:t>74</a:t>
             </a:r>
           </a:p>
         </p:txBody>
@@ -4662,7 +4689,7 @@
                 </a:solidFill>
                 <a:latin typeface="Calibri"/>
               </a:rPr>
-              <a:t>8</a:t>
+              <a:t>25</a:t>
             </a:r>
           </a:p>
         </p:txBody>

</xml_diff>